<commit_message>
kleine feinheiten geändert bei der Powerpoint
</commit_message>
<xml_diff>
--- a/AI_Spotify_Präsentation.pptx
+++ b/AI_Spotify_Präsentation.pptx
@@ -19442,7 +19442,7 @@
                 <a:effectLst/>
                 <a:latin typeface="Arial" panose="020B0604020202020204" pitchFamily="34" charset="0"/>
               </a:rPr>
-              <a:t>, Energy, </a:t>
+              <a:t>, 	Energy, </a:t>
             </a:r>
             <a:r>
               <a:rPr kumimoji="0" lang="de-DE" altLang="de-DE" sz="1700" b="0" i="0" u="none" strike="noStrike" cap="none" normalizeH="0" baseline="0" dirty="0" err="1">
@@ -19468,7 +19468,7 @@
                 <a:effectLst/>
                 <a:latin typeface="Arial" panose="020B0604020202020204" pitchFamily="34" charset="0"/>
               </a:rPr>
-              <a:t>, Tempo, Valence, Instrumentalness, </a:t>
+              <a:t>, Tempo, 	Valence, Instrumentalness, 	</a:t>
             </a:r>
             <a:r>
               <a:rPr kumimoji="0" lang="de-DE" altLang="de-DE" sz="1700" b="0" i="0" u="none" strike="noStrike" cap="none" normalizeH="0" baseline="0" dirty="0" err="1">
@@ -19569,7 +19569,7 @@
                 <a:effectLst/>
                 <a:latin typeface="Arial" panose="020B0604020202020204" pitchFamily="34" charset="0"/>
               </a:rPr>
-              <a:t>Enthält Songlänge, Popularität und weitere Metadaten</a:t>
+              <a:t>Enthält Songlänge, Popularität und 	weitere Metadaten</a:t>
             </a:r>
           </a:p>
           <a:p>

</xml_diff>